<commit_message>
fix(templates): align footer contact text boxes at top=11.40in and increase signature box widths to prevent wrapping
</commit_message>
<xml_diff>
--- a/test_5_experience.pptx
+++ b/test_5_experience.pptx
@@ -4523,7 +4523,7 @@
         </p:nvSpPr>
         <p:spPr>
           <a:xfrm>
-            <a:off x="320675" y="10428449"/>
+            <a:off x="320675" y="10424160"/>
             <a:ext cx="1457430" cy="176395"/>
           </a:xfrm>
           <a:prstGeom prst="rect">
@@ -4662,7 +4662,7 @@
         </p:nvSpPr>
         <p:spPr>
           <a:xfrm>
-            <a:off x="2886154" y="10439577"/>
+            <a:off x="2886154" y="10424160"/>
             <a:ext cx="1784191" cy="200662"/>
           </a:xfrm>
           <a:prstGeom prst="rect">
@@ -4703,7 +4703,7 @@
         </p:nvSpPr>
         <p:spPr>
           <a:xfrm>
-            <a:off x="5503313" y="10437115"/>
+            <a:off x="5503313" y="10424160"/>
             <a:ext cx="1658144" cy="200662"/>
           </a:xfrm>
           <a:prstGeom prst="rect">
@@ -4785,8 +4785,8 @@
         </p:nvSpPr>
         <p:spPr>
           <a:xfrm>
-            <a:off x="337309" y="9111758"/>
-            <a:ext cx="1721863" cy="910001"/>
+            <a:off x="337309" y="9244584"/>
+            <a:ext cx="2560320" cy="910001"/>
           </a:xfrm>
           <a:prstGeom prst="rect">
             <a:avLst/>
@@ -4802,33 +4802,37 @@
               <a:lnSpc>
                 <a:spcPts val="1425"/>
               </a:lnSpc>
-              <a:defRPr/>
+              <a:defRPr sz="909"/>
             </a:pPr>
             <a:r>
+              <a:rPr sz="909"/>
               <a:t>BEST REGARDS,</a:t>
             </a:r>
           </a:p>
           <a:p>
             <a:pPr>
-              <a:defRPr/>
+              <a:defRPr sz="909"/>
             </a:pPr>
             <a:r>
+              <a:rPr sz="909"/>
               <a:t>KARTHIKEYAN SUNDHARESAN,</a:t>
             </a:r>
           </a:p>
           <a:p>
             <a:pPr>
-              <a:defRPr/>
+              <a:defRPr sz="909"/>
             </a:pPr>
             <a:r>
+              <a:rPr sz="909"/>
               <a:t>HR TEAM HEAD,</a:t>
             </a:r>
           </a:p>
           <a:p>
             <a:pPr>
-              <a:defRPr/>
+              <a:defRPr sz="909"/>
             </a:pPr>
             <a:r>
+              <a:rPr sz="909"/>
               <a:t>COPTER CODE.</a:t>
             </a:r>
           </a:p>

</xml_diff>